<commit_message>
Update team photo in brand deck, add customer profile deck, logo-green links, theme fade
</commit_message>
<xml_diff>
--- a/Siket Digitals.pptx
+++ b/Siket Digitals.pptx
@@ -5950,7 +5950,7 @@
         </p:nvSpPr>
         <p:spPr>
           <a:xfrm>
-            <a:off x="685800" y="3840480"/>
+            <a:off x="685800" y="3840479"/>
             <a:ext cx="3383280" cy="2103120"/>
           </a:xfrm>
           <a:prstGeom prst="rect">
@@ -6052,7 +6052,7 @@
         </p:nvSpPr>
         <p:spPr>
           <a:xfrm>
-            <a:off x="4434840" y="3840480"/>
+            <a:off x="4434840" y="3840479"/>
             <a:ext cx="3383280" cy="2103120"/>
           </a:xfrm>
           <a:prstGeom prst="rect">
@@ -6154,7 +6154,7 @@
         </p:nvSpPr>
         <p:spPr>
           <a:xfrm>
-            <a:off x="8183879" y="3840480"/>
+            <a:off x="8183879" y="3840479"/>
             <a:ext cx="3383280" cy="2103120"/>
           </a:xfrm>
           <a:prstGeom prst="rect">

</xml_diff>